<commit_message>
Scrub personal identifiers from training decks
Remove names, email addresses, personal handles, and local user paths from the deck corpus while keeping examples usable with neutral placeholders. Regenerate catalog metadata and affected source/render artifacts so published deck surfaces match the sanitized sources.

Constraint: User requested scrubbing all 67 decks rather than a single slide deck.

Rejected: Leaving source PPTX/PDF/render artifacts stale | they are part of the deck source surface and would continue exposing identifiers.

Confidence: high

Scope-risk: broad

Directive: Keep future deck examples role-based or neutral; do not reintroduce person names, personal emails, personal GitHub handles, or local user paths into customer-visible training assets.

Tested: npm run validate; regex scan over decks and catalog for targeted names/emails; PPTX XML scan for targeted identifiers; pdftotext scan over source PDFs.

Not-tested: Full Slidev deck build across all decks.
</commit_message>
<xml_diff>
--- a/decks/architect-grpc-proxy-4-example-of-grpc-proxy-using-h2c/source/deck.pptx
+++ b/decks/architect-grpc-proxy-4-example-of-grpc-proxy-using-h2c/source/deck.pptx
@@ -1341,7 +1341,7 @@
                   <a:schemeClr val="dk1"/>
                 </a:solidFill>
               </a:rPr>
-              <a:t>"Once the setup is done, you can use grpcurl to send a test request through the Tyk Gateway. The -plaintext flag is important—it tells grpcurl not to use TLS, aligning with our h2c setup. If everything’s configured correctly, you'll see a friendly message returned: 'Hello joe'."</a:t>
+              <a:t>"Once the setup is done, you can use grpcurl to send a test request through the Tyk Gateway. The -plaintext flag is important—it tells grpcurl not to use TLS, aligning with our h2c setup. If everything’s configured correctly, you'll see a friendly message returned: 'Hello user'."</a:t>
             </a:r>
             <a:endParaRPr>
               <a:solidFill>
@@ -7992,7 +7992,7 @@
                 <a:cs typeface="Courier New"/>
                 <a:sym typeface="Courier New"/>
               </a:rPr>
-              <a:t>  -d '{"name": "joe"}' \</a:t>
+              <a:t>  -d '{"name": "user"}' \</a:t>
             </a:r>
             <a:endParaRPr>
               <a:solidFill>
@@ -8163,7 +8163,7 @@
                 <a:cs typeface="Courier New"/>
                 <a:sym typeface="Courier New"/>
               </a:rPr>
-              <a:t>{"message": "Hello joe"}</a:t>
+              <a:t>{"message": "Hello user"}</a:t>
             </a:r>
             <a:endParaRPr>
               <a:solidFill>

</xml_diff>